<commit_message>
Add logo to presentation
</commit_message>
<xml_diff>
--- a/Presentación Mazebank API.pptx
+++ b/Presentación Mazebank API.pptx
@@ -1852,7 +1852,7 @@
         </p:nvSpPr>
         <p:spPr>
           <a:xfrm>
-            <a:off x="1280160" y="3383280"/>
+            <a:off x="1280160" y="3208891"/>
             <a:ext cx="6583680" cy="274320"/>
           </a:xfrm>
           <a:prstGeom prst="rect">
@@ -1954,6 +1954,36 @@
           </a:p>
         </p:txBody>
       </p:sp>
+      <p:pic>
+        <p:nvPicPr>
+          <p:cNvPr id="15" name="Imagen 14">
+            <a:extLst>
+              <a:ext uri="{FF2B5EF4-FFF2-40B4-BE49-F238E27FC236}">
+                <a16:creationId xmlns:a16="http://schemas.microsoft.com/office/drawing/2014/main" id="{56F14B4C-3612-8A6F-C871-D1716C914D2E}"/>
+              </a:ext>
+            </a:extLst>
+          </p:cNvPr>
+          <p:cNvPicPr>
+            <a:picLocks noChangeAspect="1"/>
+          </p:cNvPicPr>
+          <p:nvPr/>
+        </p:nvPicPr>
+        <p:blipFill>
+          <a:blip r:embed="rId4"/>
+          <a:stretch>
+            <a:fillRect/>
+          </a:stretch>
+        </p:blipFill>
+        <p:spPr>
+          <a:xfrm>
+            <a:off x="4034790" y="3536115"/>
+            <a:ext cx="1074420" cy="1074420"/>
+          </a:xfrm>
+          <a:prstGeom prst="rect">
+            <a:avLst/>
+          </a:prstGeom>
+        </p:spPr>
+      </p:pic>
     </p:spTree>
   </p:cSld>
   <p:clrMapOvr>
@@ -8827,7 +8857,7 @@
         </p:nvSpPr>
         <p:spPr>
           <a:xfrm>
-            <a:off x="502920" y="3513903"/>
+            <a:off x="816435" y="3513903"/>
             <a:ext cx="292608" cy="292608"/>
           </a:xfrm>
           <a:prstGeom prst="rect">
@@ -8859,7 +8889,7 @@
         </p:nvSpPr>
         <p:spPr>
           <a:xfrm>
-            <a:off x="502920" y="3513903"/>
+            <a:off x="816435" y="3513903"/>
             <a:ext cx="292608" cy="292608"/>
           </a:xfrm>
           <a:prstGeom prst="rect">
@@ -8954,7 +8984,7 @@
         </p:nvSpPr>
         <p:spPr>
           <a:xfrm>
-            <a:off x="822960" y="3641919"/>
+            <a:off x="1136475" y="3641919"/>
             <a:ext cx="841248" cy="27432"/>
           </a:xfrm>
           <a:prstGeom prst="rect">
@@ -8986,7 +9016,7 @@
         </p:nvSpPr>
         <p:spPr>
           <a:xfrm>
-            <a:off x="1691640" y="3513903"/>
+            <a:off x="2005155" y="3513903"/>
             <a:ext cx="292608" cy="292608"/>
           </a:xfrm>
           <a:prstGeom prst="rect">
@@ -9018,7 +9048,7 @@
         </p:nvSpPr>
         <p:spPr>
           <a:xfrm>
-            <a:off x="1691640" y="3513903"/>
+            <a:off x="2005155" y="3513903"/>
             <a:ext cx="292608" cy="292608"/>
           </a:xfrm>
           <a:prstGeom prst="rect">
@@ -9113,7 +9143,7 @@
         </p:nvSpPr>
         <p:spPr>
           <a:xfrm>
-            <a:off x="2011680" y="3641919"/>
+            <a:off x="2325195" y="3641919"/>
             <a:ext cx="841248" cy="27432"/>
           </a:xfrm>
           <a:prstGeom prst="rect">
@@ -9145,7 +9175,7 @@
         </p:nvSpPr>
         <p:spPr>
           <a:xfrm>
-            <a:off x="2880360" y="3513903"/>
+            <a:off x="3193875" y="3513903"/>
             <a:ext cx="292608" cy="292608"/>
           </a:xfrm>
           <a:prstGeom prst="rect">
@@ -9177,7 +9207,7 @@
         </p:nvSpPr>
         <p:spPr>
           <a:xfrm>
-            <a:off x="2880360" y="3513903"/>
+            <a:off x="3193875" y="3513903"/>
             <a:ext cx="292608" cy="292608"/>
           </a:xfrm>
           <a:prstGeom prst="rect">
@@ -9272,7 +9302,7 @@
         </p:nvSpPr>
         <p:spPr>
           <a:xfrm>
-            <a:off x="3200400" y="3641919"/>
+            <a:off x="3513915" y="3641919"/>
             <a:ext cx="841248" cy="27432"/>
           </a:xfrm>
           <a:prstGeom prst="rect">
@@ -9304,7 +9334,7 @@
         </p:nvSpPr>
         <p:spPr>
           <a:xfrm>
-            <a:off x="4069080" y="3513903"/>
+            <a:off x="4382595" y="3513903"/>
             <a:ext cx="292608" cy="292608"/>
           </a:xfrm>
           <a:prstGeom prst="rect">
@@ -9336,7 +9366,7 @@
         </p:nvSpPr>
         <p:spPr>
           <a:xfrm>
-            <a:off x="4069080" y="3513903"/>
+            <a:off x="4382595" y="3513903"/>
             <a:ext cx="292608" cy="292608"/>
           </a:xfrm>
           <a:prstGeom prst="rect">
@@ -9431,7 +9461,7 @@
         </p:nvSpPr>
         <p:spPr>
           <a:xfrm>
-            <a:off x="4389120" y="3641919"/>
+            <a:off x="4702635" y="3641919"/>
             <a:ext cx="841248" cy="27432"/>
           </a:xfrm>
           <a:prstGeom prst="rect">
@@ -9463,7 +9493,7 @@
         </p:nvSpPr>
         <p:spPr>
           <a:xfrm>
-            <a:off x="5257800" y="3513903"/>
+            <a:off x="5571315" y="3513903"/>
             <a:ext cx="292608" cy="292608"/>
           </a:xfrm>
           <a:prstGeom prst="rect">
@@ -9495,7 +9525,7 @@
         </p:nvSpPr>
         <p:spPr>
           <a:xfrm>
-            <a:off x="5257800" y="3513903"/>
+            <a:off x="5571315" y="3513903"/>
             <a:ext cx="292608" cy="292608"/>
           </a:xfrm>
           <a:prstGeom prst="rect">
@@ -9590,7 +9620,7 @@
         </p:nvSpPr>
         <p:spPr>
           <a:xfrm>
-            <a:off x="5577840" y="3641919"/>
+            <a:off x="5891355" y="3641919"/>
             <a:ext cx="841248" cy="27432"/>
           </a:xfrm>
           <a:prstGeom prst="rect">
@@ -9622,7 +9652,7 @@
         </p:nvSpPr>
         <p:spPr>
           <a:xfrm>
-            <a:off x="6446520" y="3513903"/>
+            <a:off x="6760035" y="3513903"/>
             <a:ext cx="292608" cy="292608"/>
           </a:xfrm>
           <a:prstGeom prst="rect">
@@ -9654,7 +9684,7 @@
         </p:nvSpPr>
         <p:spPr>
           <a:xfrm>
-            <a:off x="6446520" y="3513903"/>
+            <a:off x="6760035" y="3513903"/>
             <a:ext cx="292608" cy="292608"/>
           </a:xfrm>
           <a:prstGeom prst="rect">
@@ -9749,7 +9779,7 @@
         </p:nvSpPr>
         <p:spPr>
           <a:xfrm>
-            <a:off x="6766560" y="3641919"/>
+            <a:off x="7080075" y="3641919"/>
             <a:ext cx="841248" cy="27432"/>
           </a:xfrm>
           <a:prstGeom prst="rect">
@@ -9781,7 +9811,7 @@
         </p:nvSpPr>
         <p:spPr>
           <a:xfrm>
-            <a:off x="7635240" y="3513903"/>
+            <a:off x="7948755" y="3513903"/>
             <a:ext cx="292608" cy="292608"/>
           </a:xfrm>
           <a:prstGeom prst="rect">
@@ -9813,7 +9843,7 @@
         </p:nvSpPr>
         <p:spPr>
           <a:xfrm>
-            <a:off x="7635240" y="3513903"/>
+            <a:off x="7948755" y="3513903"/>
             <a:ext cx="292608" cy="292608"/>
           </a:xfrm>
           <a:prstGeom prst="rect">

</xml_diff>